<commit_message>
Bosch : slides alignées sur le catalogue et les ads
Co-Authored-By: Claude Opus 5.5 <noreply@anthropic.com>
Claude-Session: https://claude.ai/code/session_01BmxtdWjbeRUyPx9e1qVLbT
</commit_message>
<xml_diff>
--- a/rapports/septembre/Bosch_sept2026.pptx
+++ b/rapports/septembre/Bosch_sept2026.pptx
@@ -5283,22 +5283,22 @@
               </a:spcAft>
             </a:pPr>
             <a:r>
+              <a:rPr sz="2000" b="1" i="0">
+                <a:solidFill>
+                  <a:srgbClr val="EE6A2C"/>
+                </a:solidFill>
+                <a:latin typeface="Arial"/>
+              </a:rPr>
+              <a:t>lave-vaisselle</a:t>
+            </a:r>
+            <a:r>
               <a:rPr sz="1800" b="1" i="0">
                 <a:solidFill>
-                  <a:srgbClr val="EE6A2C"/>
-                </a:solidFill>
-                <a:latin typeface="Arial"/>
-              </a:rPr>
-              <a:t>lave-vaisselle 60 cm</a:t>
-            </a:r>
-            <a:r>
-              <a:rPr sz="1600" b="1" i="0">
-                <a:solidFill>
                   <a:srgbClr val="111111"/>
                 </a:solidFill>
                 <a:latin typeface="Arial"/>
               </a:rPr>
-              <a:t>   silencieux</a:t>
+              <a:t>   encastrable</a:t>
             </a:r>
           </a:p>
           <a:p>
@@ -5314,7 +5314,7 @@
                 </a:solidFill>
                 <a:latin typeface="Arial"/>
               </a:rPr>
-              <a:t>rapport qualité-prix</a:t>
+              <a:t>pose libre</a:t>
             </a:r>
             <a:r>
               <a:rPr sz="1400" b="1" i="0">
@@ -5323,7 +5323,7 @@
                 </a:solidFill>
                 <a:latin typeface="Arial"/>
               </a:rPr>
-              <a:t>   encastrable</a:t>
+              <a:t>   60 cm</a:t>
             </a:r>
           </a:p>
           <a:p>
@@ -5339,7 +5339,7 @@
                 </a:solidFill>
                 <a:latin typeface="Arial"/>
               </a:rPr>
-              <a:t>bandeau apparent</a:t>
+              <a:t>45 cm</a:t>
             </a:r>
             <a:r>
               <a:rPr sz="1200" b="0" i="0">
@@ -5348,7 +5348,16 @@
                 </a:solidFill>
                 <a:latin typeface="Arial"/>
               </a:rPr>
-              <a:t>   fiabilité</a:t>
+              <a:t>   Série 2</a:t>
+            </a:r>
+            <a:r>
+              <a:rPr sz="1200" b="1" i="0">
+                <a:solidFill>
+                  <a:srgbClr val="111111"/>
+                </a:solidFill>
+                <a:latin typeface="Arial"/>
+              </a:rPr>
+              <a:t>   Série 4</a:t>
             </a:r>
           </a:p>
           <a:p>
@@ -5364,7 +5373,7 @@
                 </a:solidFill>
                 <a:latin typeface="Arial"/>
               </a:rPr>
-              <a:t>moins de 600 €</a:t>
+              <a:t>EcoSilence Drive</a:t>
             </a:r>
             <a:r>
               <a:rPr sz="1100" b="1" i="0">
@@ -5373,7 +5382,7 @@
                 </a:solidFill>
                 <a:latin typeface="Arial"/>
               </a:rPr>
-              <a:t>   Black Friday</a:t>
+              <a:t>   tiroir à couverts</a:t>
             </a:r>
           </a:p>
           <a:p>
@@ -5389,7 +5398,7 @@
                 </a:solidFill>
                 <a:latin typeface="Arial"/>
               </a:rPr>
-              <a:t>four à pyrolyse</a:t>
+              <a:t>13 couverts</a:t>
             </a:r>
             <a:r>
               <a:rPr sz="1100" b="0" i="0">
@@ -5398,7 +5407,7 @@
                 </a:solidFill>
                 <a:latin typeface="Arial"/>
               </a:rPr>
-              <a:t>   induction</a:t>
+              <a:t>   14 couverts</a:t>
             </a:r>
             <a:r>
               <a:rPr sz="1100" b="1" i="0">
@@ -5407,7 +5416,7 @@
                 </a:solidFill>
                 <a:latin typeface="Arial"/>
               </a:rPr>
-              <a:t>   airfryer</a:t>
+              <a:t>   dB</a:t>
             </a:r>
           </a:p>
           <a:p>
@@ -5423,7 +5432,7 @@
                 </a:solidFill>
                 <a:latin typeface="Arial"/>
               </a:rPr>
-              <a:t>pompe à chaleur</a:t>
+              <a:t>livraison gratuite</a:t>
             </a:r>
             <a:r>
               <a:rPr sz="1100" b="0" i="0">
@@ -5432,7 +5441,7 @@
                 </a:solidFill>
                 <a:latin typeface="Arial"/>
               </a:rPr>
-              <a:t>   compatibilité</a:t>
+              <a:t>   Black Friday</a:t>
             </a:r>
           </a:p>
         </p:txBody>
@@ -5965,45 +5974,36 @@
       </p:sp>
       <p:sp>
         <p:nvSpPr>
-          <p:cNvPr id="74" name="Rectangle 73"/>
-          <p:cNvSpPr/>
-          <p:nvPr/>
-        </p:nvSpPr>
-        <p:spPr>
-          <a:xfrm>
-            <a:off x="4437888" y="5730240"/>
-            <a:ext cx="2913888" cy="304800"/>
-          </a:xfrm>
-          <a:prstGeom prst="rect">
-            <a:avLst/>
-          </a:prstGeom>
-          <a:solidFill>
-            <a:srgbClr val="F1EFEA"/>
-          </a:solidFill>
-          <a:ln>
-            <a:noFill/>
-          </a:ln>
-          <a:effectLst/>
-        </p:spPr>
-        <p:style>
-          <a:lnRef idx="1">
-            <a:schemeClr val="accent1"/>
-          </a:lnRef>
-          <a:fillRef idx="3">
-            <a:schemeClr val="accent1"/>
-          </a:fillRef>
-          <a:effectRef idx="2">
-            <a:schemeClr val="accent1"/>
-          </a:effectRef>
-          <a:fontRef idx="minor">
-            <a:schemeClr val="lt1"/>
-          </a:fontRef>
-        </p:style>
-        <p:txBody>
-          <a:bodyPr rtlCol="0" anchor="ctr"/>
-          <a:lstStyle/>
-          <a:p>
-            <a:pPr algn="ctr"/>
+          <p:cNvPr id="74" name="TextBox 73"/>
+          <p:cNvSpPr txBox="1"/>
+          <p:nvPr/>
+        </p:nvSpPr>
+        <p:spPr>
+          <a:xfrm>
+            <a:off x="8101584" y="3767328"/>
+            <a:ext cx="2926080" cy="152400"/>
+          </a:xfrm>
+          <a:prstGeom prst="rect">
+            <a:avLst/>
+          </a:prstGeom>
+          <a:noFill/>
+        </p:spPr>
+        <p:txBody>
+          <a:bodyPr wrap="square" anchor="t" lIns="0" rIns="0" tIns="0" bIns="0">
+            <a:spAutoFit/>
+          </a:bodyPr>
+          <a:lstStyle/>
+          <a:p>
+            <a:pPr algn="l"/>
+            <a:r>
+              <a:rPr sz="1300" b="1" i="0">
+                <a:solidFill>
+                  <a:srgbClr val="555B66"/>
+                </a:solidFill>
+                <a:latin typeface="Arial"/>
+              </a:rPr>
+              <a:t>CATÉGORIES DE PRODUITS</a:t>
+            </a:r>
           </a:p>
         </p:txBody>
       </p:sp>
@@ -6015,8 +6015,8 @@
         </p:nvSpPr>
         <p:spPr>
           <a:xfrm>
-            <a:off x="4559808" y="5730240"/>
-            <a:ext cx="182880" cy="304800"/>
+            <a:off x="8101584" y="3992880"/>
+            <a:ext cx="2926080" cy="121920"/>
           </a:xfrm>
           <a:prstGeom prst="rect">
             <a:avLst/>
@@ -6024,20 +6024,20 @@
           <a:noFill/>
         </p:spPr>
         <p:txBody>
-          <a:bodyPr wrap="square" anchor="ctr" lIns="0" rIns="0" tIns="0" bIns="0">
+          <a:bodyPr wrap="square" anchor="t" lIns="0" rIns="0" tIns="0" bIns="0">
             <a:spAutoFit/>
           </a:bodyPr>
           <a:lstStyle/>
           <a:p>
             <a:pPr algn="l"/>
             <a:r>
-              <a:rPr sz="900" b="0" i="0">
-                <a:solidFill>
-                  <a:srgbClr val="555B66"/>
-                </a:solidFill>
-                <a:latin typeface="Arial"/>
-              </a:rPr>
-              <a:t>🔍</a:t>
+              <a:rPr sz="1000" b="0" i="1">
+                <a:solidFill>
+                  <a:srgbClr val="8A93A6"/>
+                </a:solidFill>
+                <a:latin typeface="Arial"/>
+              </a:rPr>
+              <a:t>Répartition des requêtes</a:t>
             </a:r>
           </a:p>
         </p:txBody>
@@ -6050,43 +6050,8 @@
         </p:nvSpPr>
         <p:spPr>
           <a:xfrm>
-            <a:off x="4791456" y="5730240"/>
-            <a:ext cx="2499360" cy="304800"/>
-          </a:xfrm>
-          <a:prstGeom prst="rect">
-            <a:avLst/>
-          </a:prstGeom>
-          <a:noFill/>
-        </p:spPr>
-        <p:txBody>
-          <a:bodyPr wrap="square" anchor="ctr" lIns="0" rIns="0" tIns="0" bIns="0">
-            <a:spAutoFit/>
-          </a:bodyPr>
-          <a:lstStyle/>
-          <a:p>
-            <a:pPr algn="l"/>
-            <a:r>
-              <a:rPr sz="900" b="0" i="0">
-                <a:solidFill>
-                  <a:srgbClr val="111111"/>
-                </a:solidFill>
-                <a:latin typeface="Arial"/>
-              </a:rPr>
-              <a:t>Quel four à pyrolyse pour une famille de 4 personnes ?</a:t>
-            </a:r>
-          </a:p>
-        </p:txBody>
-      </p:sp>
-      <p:sp>
-        <p:nvSpPr>
-          <p:cNvPr id="77" name="TextBox 76"/>
-          <p:cNvSpPr txBox="1"/>
-          <p:nvPr/>
-        </p:nvSpPr>
-        <p:spPr>
-          <a:xfrm>
-            <a:off x="8101584" y="3767328"/>
-            <a:ext cx="2926080" cy="152400"/>
+            <a:off x="10607040" y="4175760"/>
+            <a:ext cx="518160" cy="121920"/>
           </a:xfrm>
           <a:prstGeom prst="rect">
             <a:avLst/>
@@ -6099,76 +6064,6 @@
           </a:bodyPr>
           <a:lstStyle/>
           <a:p>
-            <a:pPr algn="l"/>
-            <a:r>
-              <a:rPr sz="1300" b="1" i="0">
-                <a:solidFill>
-                  <a:srgbClr val="555B66"/>
-                </a:solidFill>
-                <a:latin typeface="Arial"/>
-              </a:rPr>
-              <a:t>CATÉGORIES DE PRODUITS</a:t>
-            </a:r>
-          </a:p>
-        </p:txBody>
-      </p:sp>
-      <p:sp>
-        <p:nvSpPr>
-          <p:cNvPr id="78" name="TextBox 77"/>
-          <p:cNvSpPr txBox="1"/>
-          <p:nvPr/>
-        </p:nvSpPr>
-        <p:spPr>
-          <a:xfrm>
-            <a:off x="8101584" y="3992880"/>
-            <a:ext cx="2926080" cy="121920"/>
-          </a:xfrm>
-          <a:prstGeom prst="rect">
-            <a:avLst/>
-          </a:prstGeom>
-          <a:noFill/>
-        </p:spPr>
-        <p:txBody>
-          <a:bodyPr wrap="square" anchor="t" lIns="0" rIns="0" tIns="0" bIns="0">
-            <a:spAutoFit/>
-          </a:bodyPr>
-          <a:lstStyle/>
-          <a:p>
-            <a:pPr algn="l"/>
-            <a:r>
-              <a:rPr sz="1000" b="0" i="1">
-                <a:solidFill>
-                  <a:srgbClr val="8A93A6"/>
-                </a:solidFill>
-                <a:latin typeface="Arial"/>
-              </a:rPr>
-              <a:t>Répartition des requêtes</a:t>
-            </a:r>
-          </a:p>
-        </p:txBody>
-      </p:sp>
-      <p:sp>
-        <p:nvSpPr>
-          <p:cNvPr id="79" name="TextBox 78"/>
-          <p:cNvSpPr txBox="1"/>
-          <p:nvPr/>
-        </p:nvSpPr>
-        <p:spPr>
-          <a:xfrm>
-            <a:off x="10607040" y="4175760"/>
-            <a:ext cx="518160" cy="121920"/>
-          </a:xfrm>
-          <a:prstGeom prst="rect">
-            <a:avLst/>
-          </a:prstGeom>
-          <a:noFill/>
-        </p:spPr>
-        <p:txBody>
-          <a:bodyPr wrap="square" anchor="t" lIns="0" rIns="0" tIns="0" bIns="0">
-            <a:spAutoFit/>
-          </a:bodyPr>
-          <a:lstStyle/>
-          <a:p>
             <a:pPr algn="r"/>
             <a:r>
               <a:rPr sz="1100" b="1" i="0">
@@ -6184,7 +6079,7 @@
       </p:sp>
       <p:sp>
         <p:nvSpPr>
-          <p:cNvPr id="80" name="Rectangle 79"/>
+          <p:cNvPr id="77" name="Rectangle 76"/>
           <p:cNvSpPr/>
           <p:nvPr/>
         </p:nvSpPr>
@@ -6228,7 +6123,7 @@
       </p:sp>
       <p:sp>
         <p:nvSpPr>
-          <p:cNvPr id="81" name="TextBox 80"/>
+          <p:cNvPr id="78" name="TextBox 77"/>
           <p:cNvSpPr txBox="1"/>
           <p:nvPr/>
         </p:nvSpPr>
@@ -6250,20 +6145,20 @@
           <a:p>
             <a:pPr algn="l"/>
             <a:r>
-              <a:rPr sz="1000" b="0" i="0">
+              <a:rPr sz="800" b="0" i="0">
                 <a:solidFill>
                   <a:srgbClr val="111111"/>
                 </a:solidFill>
                 <a:latin typeface="Arial"/>
               </a:rPr>
-              <a:t>Comparaison marques et modèles</a:t>
-            </a:r>
-          </a:p>
-        </p:txBody>
-      </p:sp>
-      <p:sp>
-        <p:nvSpPr>
-          <p:cNvPr id="82" name="Rectangle 81"/>
+              <a:t>Comparaison marques et modèles · 5 %</a:t>
+            </a:r>
+          </a:p>
+        </p:txBody>
+      </p:sp>
+      <p:sp>
+        <p:nvSpPr>
+          <p:cNvPr id="79" name="Rectangle 78"/>
           <p:cNvSpPr/>
           <p:nvPr/>
         </p:nvSpPr>
@@ -6307,7 +6202,7 @@
       </p:sp>
       <p:sp>
         <p:nvSpPr>
-          <p:cNvPr id="83" name="TextBox 82"/>
+          <p:cNvPr id="80" name="TextBox 79"/>
           <p:cNvSpPr txBox="1"/>
           <p:nvPr/>
         </p:nvSpPr>
@@ -6329,20 +6224,20 @@
           <a:p>
             <a:pPr algn="l"/>
             <a:r>
-              <a:rPr sz="1000" b="0" i="0">
+              <a:rPr sz="800" b="0" i="0">
                 <a:solidFill>
                   <a:srgbClr val="111111"/>
                 </a:solidFill>
                 <a:latin typeface="Arial"/>
               </a:rPr>
-              <a:t>Encastrables et intégrables · 7 %</a:t>
-            </a:r>
-          </a:p>
-        </p:txBody>
-      </p:sp>
-      <p:sp>
-        <p:nvSpPr>
-          <p:cNvPr id="84" name="Rectangle 83"/>
+              <a:t>Encastrables et intégrables · 46 %</a:t>
+            </a:r>
+          </a:p>
+        </p:txBody>
+      </p:sp>
+      <p:sp>
+        <p:nvSpPr>
+          <p:cNvPr id="81" name="Rectangle 80"/>
           <p:cNvSpPr/>
           <p:nvPr/>
         </p:nvSpPr>
@@ -6386,7 +6281,7 @@
       </p:sp>
       <p:sp>
         <p:nvSpPr>
-          <p:cNvPr id="85" name="TextBox 84"/>
+          <p:cNvPr id="82" name="TextBox 81"/>
           <p:cNvSpPr txBox="1"/>
           <p:nvPr/>
         </p:nvSpPr>
@@ -6414,14 +6309,14 @@
                 </a:solidFill>
                 <a:latin typeface="Arial"/>
               </a:rPr>
-              <a:t>Compacts et largeur 45 cm · &lt; 1 %</a:t>
-            </a:r>
-          </a:p>
-        </p:txBody>
-      </p:sp>
-      <p:sp>
-        <p:nvSpPr>
-          <p:cNvPr id="86" name="Rectangle 85"/>
+              <a:t>Compacts et largeur 45 cm · 15 %</a:t>
+            </a:r>
+          </a:p>
+        </p:txBody>
+      </p:sp>
+      <p:sp>
+        <p:nvSpPr>
+          <p:cNvPr id="83" name="Rectangle 82"/>
           <p:cNvSpPr/>
           <p:nvPr/>
         </p:nvSpPr>
@@ -6465,7 +6360,7 @@
       </p:sp>
       <p:sp>
         <p:nvSpPr>
-          <p:cNvPr id="87" name="TextBox 86"/>
+          <p:cNvPr id="84" name="TextBox 83"/>
           <p:cNvSpPr txBox="1"/>
           <p:nvPr/>
         </p:nvSpPr>
@@ -6493,14 +6388,14 @@
                 </a:solidFill>
                 <a:latin typeface="Arial"/>
               </a:rPr>
-              <a:t>Grande capacité et 60 cm · 47 %</a:t>
-            </a:r>
-          </a:p>
-        </p:txBody>
-      </p:sp>
-      <p:sp>
-        <p:nvSpPr>
-          <p:cNvPr id="88" name="Rectangle 87"/>
+              <a:t>Grande capacité et 60 cm · 34 %</a:t>
+            </a:r>
+          </a:p>
+        </p:txBody>
+      </p:sp>
+      <p:sp>
+        <p:nvSpPr>
+          <p:cNvPr id="85" name="Rectangle 84"/>
           <p:cNvSpPr/>
           <p:nvPr/>
         </p:nvSpPr>
@@ -6544,7 +6439,7 @@
       </p:sp>
       <p:sp>
         <p:nvSpPr>
-          <p:cNvPr id="89" name="TextBox 88"/>
+          <p:cNvPr id="86" name="TextBox 85"/>
           <p:cNvSpPr txBox="1"/>
           <p:nvPr/>
         </p:nvSpPr>
@@ -6579,7 +6474,7 @@
       </p:sp>
       <p:sp>
         <p:nvSpPr>
-          <p:cNvPr id="90" name="Rectangle 89"/>
+          <p:cNvPr id="87" name="Rectangle 86"/>
           <p:cNvSpPr/>
           <p:nvPr/>
         </p:nvSpPr>
@@ -6623,7 +6518,7 @@
       </p:sp>
       <p:sp>
         <p:nvSpPr>
-          <p:cNvPr id="91" name="TextBox 90"/>
+          <p:cNvPr id="88" name="TextBox 87"/>
           <p:cNvSpPr txBox="1"/>
           <p:nvPr/>
         </p:nvSpPr>
@@ -6658,14 +6553,14 @@
       </p:sp>
       <p:sp>
         <p:nvSpPr>
-          <p:cNvPr id="92" name="Rectangle 91"/>
+          <p:cNvPr id="89" name="Rectangle 88"/>
           <p:cNvSpPr/>
           <p:nvPr/>
         </p:nvSpPr>
         <p:spPr>
           <a:xfrm>
             <a:off x="10564368" y="4450080"/>
-            <a:ext cx="475488" cy="616915"/>
+            <a:ext cx="475488" cy="67056"/>
           </a:xfrm>
           <a:prstGeom prst="rect">
             <a:avLst/>
@@ -6702,49 +6597,14 @@
       </p:sp>
       <p:sp>
         <p:nvSpPr>
-          <p:cNvPr id="93" name="TextBox 92"/>
-          <p:cNvSpPr txBox="1"/>
-          <p:nvPr/>
-        </p:nvSpPr>
-        <p:spPr>
-          <a:xfrm>
-            <a:off x="10564368" y="4450080"/>
+          <p:cNvPr id="90" name="Rectangle 89"/>
+          <p:cNvSpPr/>
+          <p:nvPr/>
+        </p:nvSpPr>
+        <p:spPr>
+          <a:xfrm>
+            <a:off x="10564368" y="4517136"/>
             <a:ext cx="475488" cy="616915"/>
-          </a:xfrm>
-          <a:prstGeom prst="rect">
-            <a:avLst/>
-          </a:prstGeom>
-          <a:noFill/>
-        </p:spPr>
-        <p:txBody>
-          <a:bodyPr wrap="square" anchor="ctr" lIns="0" rIns="0" tIns="0" bIns="0">
-            <a:spAutoFit/>
-          </a:bodyPr>
-          <a:lstStyle/>
-          <a:p>
-            <a:pPr algn="ctr"/>
-            <a:r>
-              <a:rPr sz="1000" b="1" i="0">
-                <a:solidFill>
-                  <a:srgbClr val="FFFFFF"/>
-                </a:solidFill>
-                <a:latin typeface="Arial"/>
-              </a:rPr>
-              <a:t>46 %</a:t>
-            </a:r>
-          </a:p>
-        </p:txBody>
-      </p:sp>
-      <p:sp>
-        <p:nvSpPr>
-          <p:cNvPr id="94" name="Rectangle 93"/>
-          <p:cNvSpPr/>
-          <p:nvPr/>
-        </p:nvSpPr>
-        <p:spPr>
-          <a:xfrm>
-            <a:off x="10564368" y="5066995"/>
-            <a:ext cx="475488" cy="93878"/>
           </a:xfrm>
           <a:prstGeom prst="rect">
             <a:avLst/>
@@ -6781,14 +6641,49 @@
       </p:sp>
       <p:sp>
         <p:nvSpPr>
-          <p:cNvPr id="95" name="Rectangle 94"/>
+          <p:cNvPr id="91" name="TextBox 90"/>
+          <p:cNvSpPr txBox="1"/>
+          <p:nvPr/>
+        </p:nvSpPr>
+        <p:spPr>
+          <a:xfrm>
+            <a:off x="10564368" y="4517136"/>
+            <a:ext cx="475488" cy="616915"/>
+          </a:xfrm>
+          <a:prstGeom prst="rect">
+            <a:avLst/>
+          </a:prstGeom>
+          <a:noFill/>
+        </p:spPr>
+        <p:txBody>
+          <a:bodyPr wrap="square" anchor="ctr" lIns="0" rIns="0" tIns="0" bIns="0">
+            <a:spAutoFit/>
+          </a:bodyPr>
+          <a:lstStyle/>
+          <a:p>
+            <a:pPr algn="ctr"/>
+            <a:r>
+              <a:rPr sz="1000" b="1" i="0">
+                <a:solidFill>
+                  <a:srgbClr val="FFFFFF"/>
+                </a:solidFill>
+                <a:latin typeface="Arial"/>
+              </a:rPr>
+              <a:t>46 %</a:t>
+            </a:r>
+          </a:p>
+        </p:txBody>
+      </p:sp>
+      <p:sp>
+        <p:nvSpPr>
+          <p:cNvPr id="92" name="Rectangle 91"/>
           <p:cNvSpPr/>
           <p:nvPr/>
         </p:nvSpPr>
         <p:spPr>
           <a:xfrm>
-            <a:off x="10564368" y="5160873"/>
-            <a:ext cx="475488" cy="0"/>
+            <a:off x="10564368" y="5134051"/>
+            <a:ext cx="475488" cy="201168"/>
           </a:xfrm>
           <a:prstGeom prst="rect">
             <a:avLst/>
@@ -6825,14 +6720,14 @@
       </p:sp>
       <p:sp>
         <p:nvSpPr>
-          <p:cNvPr id="96" name="Rectangle 95"/>
+          <p:cNvPr id="93" name="Rectangle 92"/>
           <p:cNvSpPr/>
           <p:nvPr/>
         </p:nvSpPr>
         <p:spPr>
           <a:xfrm>
-            <a:off x="10564368" y="5160873"/>
-            <a:ext cx="475488" cy="630326"/>
+            <a:off x="10564368" y="5335219"/>
+            <a:ext cx="475488" cy="455980"/>
           </a:xfrm>
           <a:prstGeom prst="rect">
             <a:avLst/>
@@ -6869,14 +6764,14 @@
       </p:sp>
       <p:sp>
         <p:nvSpPr>
-          <p:cNvPr id="97" name="TextBox 96"/>
+          <p:cNvPr id="94" name="TextBox 93"/>
           <p:cNvSpPr txBox="1"/>
           <p:nvPr/>
         </p:nvSpPr>
         <p:spPr>
           <a:xfrm>
-            <a:off x="10564368" y="5160873"/>
-            <a:ext cx="475488" cy="630326"/>
+            <a:off x="10564368" y="5335219"/>
+            <a:ext cx="475488" cy="455980"/>
           </a:xfrm>
           <a:prstGeom prst="rect">
             <a:avLst/>
@@ -6897,14 +6792,14 @@
                 </a:solidFill>
                 <a:latin typeface="Arial"/>
               </a:rPr>
-              <a:t>47 %</a:t>
-            </a:r>
-          </a:p>
-        </p:txBody>
-      </p:sp>
-      <p:sp>
-        <p:nvSpPr>
-          <p:cNvPr id="98" name="Rectangle 97"/>
+              <a:t>34 %</a:t>
+            </a:r>
+          </a:p>
+        </p:txBody>
+      </p:sp>
+      <p:sp>
+        <p:nvSpPr>
+          <p:cNvPr id="95" name="Rectangle 94"/>
           <p:cNvSpPr/>
           <p:nvPr/>
         </p:nvSpPr>
@@ -6948,7 +6843,7 @@
       </p:sp>
       <p:sp>
         <p:nvSpPr>
-          <p:cNvPr id="99" name="Rectangle 98"/>
+          <p:cNvPr id="96" name="Rectangle 95"/>
           <p:cNvSpPr/>
           <p:nvPr/>
         </p:nvSpPr>
@@ -7391,7 +7286,7 @@
                 </a:solidFill>
                 <a:latin typeface="Arial"/>
               </a:rPr>
-              <a:t>Mettre en avant les modèles encastrables</a:t>
+              <a:t>Les modèles Série 2 cliquent le mieux</a:t>
             </a:r>
           </a:p>
         </p:txBody>
@@ -7426,7 +7321,7 @@
                 </a:solidFill>
                 <a:latin typeface="Arial"/>
               </a:rPr>
-              <a:t>Les lave-vaisselle tout encastrables et semi-encastrables atteignent 1,28 fois le CTR moyen. Ils ne représentent pourtant que 7 % de la diffusion.</a:t>
+              <a:t>Les lave-vaisselle Série 2 atteignent 1,06 fois le CTR moyen, contre 0,95 fois pour les Série 4. Le Série 2 tout encastrable SMV2HTX02E atteint 1,41 fois.</a:t>
             </a:r>
           </a:p>
         </p:txBody>
@@ -7461,7 +7356,7 @@
                 </a:solidFill>
                 <a:latin typeface="Arial"/>
               </a:rPr>
-              <a:t>→  Augmenter la part des modèles encastrables dans la diffusion.</a:t>
+              <a:t>→  Mettre en avant les Série 2 avec un argument prix.</a:t>
             </a:r>
           </a:p>
         </p:txBody>
@@ -7577,7 +7472,7 @@
                 </a:solidFill>
                 <a:latin typeface="Arial"/>
               </a:rPr>
-              <a:t>Les modèles d'entrée de gamme cliquent le mieux</a:t>
+              <a:t>Des écarts forts d'un modèle à l'autre</a:t>
             </a:r>
           </a:p>
         </p:txBody>
@@ -7612,7 +7507,7 @@
                 </a:solidFill>
                 <a:latin typeface="Arial"/>
               </a:rPr>
-              <a:t>Les Série 2 sont en tête (jusqu'à 1,41 fois la moyenne). Plusieurs Série 4 restent sous la moyenne (0,60 à 0,71 fois).</a:t>
+              <a:t>Avec la même description, les modèles vont de 0,60 fois (Série 4 SBV4HCX07E) à 1,41 fois la moyenne.</a:t>
             </a:r>
           </a:p>
         </p:txBody>
@@ -7647,7 +7542,7 @@
                 </a:solidFill>
                 <a:latin typeface="Arial"/>
               </a:rPr>
-              <a:t>→  Mettre en avant les Série 2 avec un argument prix, et les Série 4 avec un bénéfice précis.</a:t>
+              <a:t>→  Concentrer la diffusion sur les modèles qui cliquent le plus et retirer les moins performants.</a:t>
             </a:r>
           </a:p>
         </p:txBody>
@@ -7763,7 +7658,7 @@
                 </a:solidFill>
                 <a:latin typeface="Arial"/>
               </a:rPr>
-              <a:t>Le silence est un argument fort</a:t>
+              <a:t>Varier les descriptions</a:t>
             </a:r>
           </a:p>
         </p:txBody>
@@ -7798,7 +7693,7 @@
                 </a:solidFill>
                 <a:latin typeface="Arial"/>
               </a:rPr>
-              <a:t>Le modèle pose libre à 38 dB fait partie des meilleures annonces (1,30 fois la moyenne).</a:t>
+              <a:t>52 des 53 annonces utilisent la même description (« Cdiscount Electroménager - Découvrez notre offre… »), qui reprend la fiche technique.</a:t>
             </a:r>
           </a:p>
         </p:txBody>
@@ -7833,7 +7728,7 @@
                 </a:solidFill>
                 <a:latin typeface="Arial"/>
               </a:rPr>
-              <a:t>→  Mettre le niveau sonore en avant dans les accroches, surtout pour les cuisines ouvertes.</a:t>
+              <a:t>→  Tester des descriptions centrées sur un bénéfice (silence en cuisine ouverte, gain de place, économie d'eau).</a:t>
             </a:r>
           </a:p>
         </p:txBody>

</xml_diff>